<commit_message>
feat: complete hackathon analytics pipeline, market insights, career simulator, formal approach note, and enhanced profile extraction
</commit_message>
<xml_diff>
--- a/CareerPath_AI_Presentation.pptx
+++ b/CareerPath_AI_Presentation.pptx
@@ -137,7 +137,7 @@
 <file path=ppt/revisionInfo.xml><?xml version="1.0" encoding="utf-8"?>
 <p1510:revInfo xmlns:a="http://schemas.openxmlformats.org/drawingml/2006/main" xmlns:r="http://schemas.openxmlformats.org/officeDocument/2006/relationships" xmlns:p1510="http://schemas.microsoft.com/office/powerpoint/2015/10/main">
   <p1510:revLst>
-    <p1510:client id="{16840E4F-AFC4-49B9-B33F-5D147A63F135}" v="1" dt="2026-09-25T17:58:05.567"/>
+    <p1510:client id="{16840E4F-AFC4-49B9-B33F-5D147A63F135}" v="3" dt="2026-10-07T07:28:20.498"/>
   </p1510:revLst>
 </p1510:revInfo>
 </file>
@@ -146,19 +146,19 @@
 <pc:chgInfo xmlns:a="http://schemas.openxmlformats.org/drawingml/2006/main" xmlns:r="http://schemas.openxmlformats.org/officeDocument/2006/relationships" xmlns:ac="http://schemas.microsoft.com/office/drawing/2013/main/command" xmlns:pc="http://schemas.microsoft.com/office/powerpoint/2013/main/command">
   <pc:docChgLst>
     <pc:chgData name="rashmiroy2004@outlook.com" userId="9b262ceecccdb4c8" providerId="LiveId" clId="{9DE611EF-83A3-4266-B8CA-B23D7C9EA60E}"/>
-    <pc:docChg chg="custSel delSld modSld">
-      <pc:chgData name="rashmiroy2004@outlook.com" userId="9b262ceecccdb4c8" providerId="LiveId" clId="{9DE611EF-83A3-4266-B8CA-B23D7C9EA60E}" dt="2026-09-25T18:02:46.179" v="237" actId="1076"/>
+    <pc:docChg chg="undo custSel delSld modSld">
+      <pc:chgData name="rashmiroy2004@outlook.com" userId="9b262ceecccdb4c8" providerId="LiveId" clId="{9DE611EF-83A3-4266-B8CA-B23D7C9EA60E}" dt="2026-10-07T07:29:55.947" v="323" actId="1035"/>
       <pc:docMkLst>
         <pc:docMk/>
       </pc:docMkLst>
       <pc:sldChg chg="addSp delSp modSp mod">
-        <pc:chgData name="rashmiroy2004@outlook.com" userId="9b262ceecccdb4c8" providerId="LiveId" clId="{9DE611EF-83A3-4266-B8CA-B23D7C9EA60E}" dt="2026-09-25T18:01:45.525" v="229" actId="207"/>
+        <pc:chgData name="rashmiroy2004@outlook.com" userId="9b262ceecccdb4c8" providerId="LiveId" clId="{9DE611EF-83A3-4266-B8CA-B23D7C9EA60E}" dt="2026-10-07T07:29:55.947" v="323" actId="1035"/>
         <pc:sldMkLst>
           <pc:docMk/>
           <pc:sldMk cId="0" sldId="256"/>
         </pc:sldMkLst>
         <pc:spChg chg="mod">
-          <ac:chgData name="rashmiroy2004@outlook.com" userId="9b262ceecccdb4c8" providerId="LiveId" clId="{9DE611EF-83A3-4266-B8CA-B23D7C9EA60E}" dt="2026-09-25T18:00:14.127" v="162" actId="1076"/>
+          <ac:chgData name="rashmiroy2004@outlook.com" userId="9b262ceecccdb4c8" providerId="LiveId" clId="{9DE611EF-83A3-4266-B8CA-B23D7C9EA60E}" dt="2026-10-07T07:28:19.801" v="240" actId="1076"/>
           <ac:spMkLst>
             <pc:docMk/>
             <pc:sldMk cId="0" sldId="256"/>
@@ -222,7 +222,7 @@
           </ac:spMkLst>
         </pc:spChg>
         <pc:spChg chg="mod">
-          <ac:chgData name="rashmiroy2004@outlook.com" userId="9b262ceecccdb4c8" providerId="LiveId" clId="{9DE611EF-83A3-4266-B8CA-B23D7C9EA60E}" dt="2026-09-25T18:01:45.525" v="229" actId="207"/>
+          <ac:chgData name="rashmiroy2004@outlook.com" userId="9b262ceecccdb4c8" providerId="LiveId" clId="{9DE611EF-83A3-4266-B8CA-B23D7C9EA60E}" dt="2026-10-07T07:29:37.230" v="279" actId="207"/>
           <ac:spMkLst>
             <pc:docMk/>
             <pc:sldMk cId="0" sldId="256"/>
@@ -237,12 +237,12 @@
             <ac:spMk id="25" creationId="{5167DDEF-D725-BD42-FBFC-0C19917B1FB6}"/>
           </ac:spMkLst>
         </pc:spChg>
-        <pc:spChg chg="add del">
-          <ac:chgData name="rashmiroy2004@outlook.com" userId="9b262ceecccdb4c8" providerId="LiveId" clId="{9DE611EF-83A3-4266-B8CA-B23D7C9EA60E}" dt="2026-09-25T17:58:13.154" v="126" actId="478"/>
+        <pc:spChg chg="add mod">
+          <ac:chgData name="rashmiroy2004@outlook.com" userId="9b262ceecccdb4c8" providerId="LiveId" clId="{9DE611EF-83A3-4266-B8CA-B23D7C9EA60E}" dt="2026-10-07T07:29:55.947" v="323" actId="1035"/>
           <ac:spMkLst>
             <pc:docMk/>
             <pc:sldMk cId="0" sldId="256"/>
-            <ac:spMk id="27" creationId="{00248607-1F42-FECC-37EA-FA8EFCC98762}"/>
+            <ac:spMk id="26" creationId="{110A6491-C4F9-59A4-8131-254FA28F1F7A}"/>
           </ac:spMkLst>
         </pc:spChg>
       </pc:sldChg>
@@ -300,13 +300,6 @@
             <ac:spMk id="35" creationId="{00000000-0000-0000-0000-000000000000}"/>
           </ac:spMkLst>
         </pc:spChg>
-      </pc:sldChg>
-      <pc:sldChg chg="del">
-        <pc:chgData name="rashmiroy2004@outlook.com" userId="9b262ceecccdb4c8" providerId="LiveId" clId="{9DE611EF-83A3-4266-B8CA-B23D7C9EA60E}" dt="2026-09-25T18:01:59.859" v="230" actId="47"/>
-        <pc:sldMkLst>
-          <pc:docMk/>
-          <pc:sldMk cId="0" sldId="268"/>
-        </pc:sldMkLst>
       </pc:sldChg>
     </pc:docChg>
   </pc:docChgLst>
@@ -658,7 +651,7 @@
           <a:p>
             <a:fld id="{5BCAD085-E8A6-8845-BD4E-CB4CCA059FC4}" type="datetimeFigureOut">
               <a:rPr lang="en-US" smtClean="0"/>
-              <a:t>9/25/2026</a:t>
+              <a:t>10/7/2026</a:t>
             </a:fld>
             <a:endParaRPr lang="en-US"/>
           </a:p>
@@ -826,7 +819,7 @@
           <a:p>
             <a:fld id="{5BCAD085-E8A6-8845-BD4E-CB4CCA059FC4}" type="datetimeFigureOut">
               <a:rPr lang="en-US" smtClean="0"/>
-              <a:t>9/25/2026</a:t>
+              <a:t>10/7/2026</a:t>
             </a:fld>
             <a:endParaRPr lang="en-US"/>
           </a:p>
@@ -1004,7 +997,7 @@
           <a:p>
             <a:fld id="{5BCAD085-E8A6-8845-BD4E-CB4CCA059FC4}" type="datetimeFigureOut">
               <a:rPr lang="en-US" smtClean="0"/>
-              <a:t>9/25/2026</a:t>
+              <a:t>10/7/2026</a:t>
             </a:fld>
             <a:endParaRPr lang="en-US"/>
           </a:p>
@@ -1172,7 +1165,7 @@
           <a:p>
             <a:fld id="{5BCAD085-E8A6-8845-BD4E-CB4CCA059FC4}" type="datetimeFigureOut">
               <a:rPr lang="en-US" smtClean="0"/>
-              <a:t>9/25/2026</a:t>
+              <a:t>10/7/2026</a:t>
             </a:fld>
             <a:endParaRPr lang="en-US"/>
           </a:p>
@@ -1417,7 +1410,7 @@
           <a:p>
             <a:fld id="{5BCAD085-E8A6-8845-BD4E-CB4CCA059FC4}" type="datetimeFigureOut">
               <a:rPr lang="en-US" smtClean="0"/>
-              <a:t>9/25/2026</a:t>
+              <a:t>10/7/2026</a:t>
             </a:fld>
             <a:endParaRPr lang="en-US"/>
           </a:p>
@@ -1702,7 +1695,7 @@
           <a:p>
             <a:fld id="{5BCAD085-E8A6-8845-BD4E-CB4CCA059FC4}" type="datetimeFigureOut">
               <a:rPr lang="en-US" smtClean="0"/>
-              <a:t>9/25/2026</a:t>
+              <a:t>10/7/2026</a:t>
             </a:fld>
             <a:endParaRPr lang="en-US"/>
           </a:p>
@@ -2121,7 +2114,7 @@
           <a:p>
             <a:fld id="{5BCAD085-E8A6-8845-BD4E-CB4CCA059FC4}" type="datetimeFigureOut">
               <a:rPr lang="en-US" smtClean="0"/>
-              <a:t>9/25/2026</a:t>
+              <a:t>10/7/2026</a:t>
             </a:fld>
             <a:endParaRPr lang="en-US"/>
           </a:p>
@@ -2238,7 +2231,7 @@
           <a:p>
             <a:fld id="{5BCAD085-E8A6-8845-BD4E-CB4CCA059FC4}" type="datetimeFigureOut">
               <a:rPr lang="en-US" smtClean="0"/>
-              <a:t>9/25/2026</a:t>
+              <a:t>10/7/2026</a:t>
             </a:fld>
             <a:endParaRPr lang="en-US"/>
           </a:p>
@@ -2333,7 +2326,7 @@
           <a:p>
             <a:fld id="{5BCAD085-E8A6-8845-BD4E-CB4CCA059FC4}" type="datetimeFigureOut">
               <a:rPr lang="en-US" smtClean="0"/>
-              <a:t>9/25/2026</a:t>
+              <a:t>10/7/2026</a:t>
             </a:fld>
             <a:endParaRPr lang="en-US"/>
           </a:p>
@@ -2608,7 +2601,7 @@
           <a:p>
             <a:fld id="{5BCAD085-E8A6-8845-BD4E-CB4CCA059FC4}" type="datetimeFigureOut">
               <a:rPr lang="en-US" smtClean="0"/>
-              <a:t>9/25/2026</a:t>
+              <a:t>10/7/2026</a:t>
             </a:fld>
             <a:endParaRPr lang="en-US"/>
           </a:p>
@@ -2860,7 +2853,7 @@
           <a:p>
             <a:fld id="{5BCAD085-E8A6-8845-BD4E-CB4CCA059FC4}" type="datetimeFigureOut">
               <a:rPr lang="en-US" smtClean="0"/>
-              <a:t>9/25/2026</a:t>
+              <a:t>10/7/2026</a:t>
             </a:fld>
             <a:endParaRPr lang="en-US"/>
           </a:p>
@@ -3071,7 +3064,7 @@
           <a:p>
             <a:fld id="{5BCAD085-E8A6-8845-BD4E-CB4CCA059FC4}" type="datetimeFigureOut">
               <a:rPr lang="en-US" smtClean="0"/>
-              <a:t>9/25/2026</a:t>
+              <a:t>10/7/2026</a:t>
             </a:fld>
             <a:endParaRPr lang="en-US"/>
           </a:p>
@@ -4193,6 +4186,7 @@
               </a:defRPr>
             </a:pPr>
             <a:r>
+              <a:rPr dirty="0"/>
               <a:t>ML / NLP Engineer</a:t>
             </a:r>
           </a:p>
@@ -4333,7 +4327,7 @@
         <p:spPr>
           <a:xfrm>
             <a:off x="8309794" y="5240889"/>
-            <a:ext cx="1265090" cy="446276"/>
+            <a:ext cx="1239442" cy="800219"/>
           </a:xfrm>
           <a:prstGeom prst="rect">
             <a:avLst/>
@@ -4391,9 +4385,51 @@
               </a:rPr>
               <a:t>Full Stack Developer</a:t>
             </a:r>
+          </a:p>
+          <a:p>
+            <a:pPr>
+              <a:defRPr sz="1000">
+                <a:solidFill>
+                  <a:srgbClr val="93C5FD"/>
+                </a:solidFill>
+              </a:defRPr>
+            </a:pPr>
+            <a:r>
+              <a:rPr lang="en-US" sz="1000" dirty="0">
+                <a:solidFill>
+                  <a:schemeClr val="accent5"/>
+                </a:solidFill>
+              </a:rPr>
+              <a:t> </a:t>
+            </a:r>
+            <a:r>
+              <a:rPr lang="en-US" sz="1300" b="1" dirty="0">
+                <a:solidFill>
+                  <a:schemeClr val="bg1"/>
+                </a:solidFill>
+              </a:rPr>
+              <a:t>Sonal</a:t>
+            </a:r>
+          </a:p>
+          <a:p>
+            <a:pPr>
+              <a:defRPr sz="1000">
+                <a:solidFill>
+                  <a:srgbClr val="93C5FD"/>
+                </a:solidFill>
+              </a:defRPr>
+            </a:pPr>
+            <a:r>
+              <a:rPr lang="en-US" sz="1000" dirty="0">
+                <a:solidFill>
+                  <a:schemeClr val="accent1"/>
+                </a:solidFill>
+              </a:rPr>
+              <a:t>Full stack Developer</a:t>
+            </a:r>
             <a:endParaRPr sz="1000" dirty="0">
               <a:solidFill>
-                <a:schemeClr val="accent5"/>
+                <a:schemeClr val="accent1"/>
               </a:solidFill>
             </a:endParaRPr>
           </a:p>
@@ -4414,6 +4450,56 @@
         <p:spPr>
           <a:xfrm>
             <a:off x="8097356" y="5331642"/>
+            <a:ext cx="109728" cy="109728"/>
+          </a:xfrm>
+          <a:prstGeom prst="ellipse">
+            <a:avLst/>
+          </a:prstGeom>
+          <a:solidFill>
+            <a:srgbClr val="3B82F6"/>
+          </a:solidFill>
+          <a:ln>
+            <a:noFill/>
+          </a:ln>
+        </p:spPr>
+        <p:style>
+          <a:lnRef idx="1">
+            <a:schemeClr val="accent1"/>
+          </a:lnRef>
+          <a:fillRef idx="3">
+            <a:schemeClr val="accent1"/>
+          </a:fillRef>
+          <a:effectRef idx="2">
+            <a:schemeClr val="accent1"/>
+          </a:effectRef>
+          <a:fontRef idx="minor">
+            <a:schemeClr val="lt1"/>
+          </a:fontRef>
+        </p:style>
+        <p:txBody>
+          <a:bodyPr rtlCol="0" anchor="ctr"/>
+          <a:lstStyle/>
+          <a:p>
+            <a:pPr algn="ctr"/>
+            <a:endParaRPr/>
+          </a:p>
+        </p:txBody>
+      </p:sp>
+      <p:sp>
+        <p:nvSpPr>
+          <p:cNvPr id="26" name="Oval 25">
+            <a:extLst>
+              <a:ext uri="{FF2B5EF4-FFF2-40B4-BE49-F238E27FC236}">
+                <a16:creationId xmlns:a16="http://schemas.microsoft.com/office/drawing/2014/main" id="{110A6491-C4F9-59A4-8131-254FA28F1F7A}"/>
+              </a:ext>
+            </a:extLst>
+          </p:cNvPr>
+          <p:cNvSpPr/>
+          <p:nvPr/>
+        </p:nvSpPr>
+        <p:spPr>
+          <a:xfrm>
+            <a:off x="8092443" y="5690523"/>
             <a:ext cx="109728" cy="109728"/>
           </a:xfrm>
           <a:prstGeom prst="ellipse">

</xml_diff>